<commit_message>
feat: add script to programmatically insert an academic timeline subbanner into slide 19 of the presentation
</commit_message>
<xml_diff>
--- a/Medical_Specialty_Classification_Presentation_updated.pptx
+++ b/Medical_Specialty_Classification_Presentation_updated.pptx
@@ -14580,6 +14580,61 @@
           </a:p>
         </p:txBody>
       </p:sp>
+      <p:sp>
+        <p:nvSpPr>
+          <p:cNvPr id="12" name="Rounded Rectangle 11"/>
+          <p:cNvSpPr/>
+          <p:nvPr/>
+        </p:nvSpPr>
+        <p:spPr>
+          <a:xfrm>
+            <a:off x="457200" y="1371600"/>
+            <a:ext cx="11247120" cy="365760"/>
+          </a:xfrm>
+          <a:prstGeom prst="roundRect">
+            <a:avLst/>
+          </a:prstGeom>
+          <a:solidFill>
+            <a:srgbClr val="EEF6F6"/>
+          </a:solidFill>
+          <a:ln w="12700">
+            <a:solidFill>
+              <a:srgbClr val="0E7C86"/>
+            </a:solidFill>
+          </a:ln>
+        </p:spPr>
+        <p:style>
+          <a:lnRef idx="1">
+            <a:schemeClr val="accent1"/>
+          </a:lnRef>
+          <a:fillRef idx="3">
+            <a:schemeClr val="accent1"/>
+          </a:fillRef>
+          <a:effectRef idx="2">
+            <a:schemeClr val="accent1"/>
+          </a:effectRef>
+          <a:fontRef idx="minor">
+            <a:schemeClr val="lt1"/>
+          </a:fontRef>
+        </p:style>
+        <p:txBody>
+          <a:bodyPr rtlCol="0" anchor="ctr" tIns="54864" bIns="54864"/>
+          <a:lstStyle/>
+          <a:p>
+            <a:pPr algn="ctr">
+              <a:defRPr sz="1100" b="1">
+                <a:solidFill>
+                  <a:srgbClr val="0E7C86"/>
+                </a:solidFill>
+                <a:latin typeface="Calibri"/>
+              </a:defRPr>
+            </a:pPr>
+            <a:r>
+              <a:t>ACADEMIC TIMELINE &amp; PRESENTATION MILESTONES (SEMESTER 3 MCA MINI PROJECT)</a:t>
+            </a:r>
+          </a:p>
+        </p:txBody>
+      </p:sp>
     </p:spTree>
   </p:cSld>
   <p:clrMapOvr>

</xml_diff>